<commit_message>
Align dependent presentations and bind current maintenance outputs
</commit_message>
<xml_diff>
--- a/edities/books34-v3/books/book-4/chapters/4.1/paragraph-pdfs/4.1.1 Toetreding, uittreding en langetermijnevenwicht – presentatie.pptx
+++ b/edities/books34-v3/books/book-4/chapters/4.1/paragraph-pdfs/4.1.1 Toetreding, uittreding en langetermijnevenwicht – presentatie.pptx
@@ -530,19 +530,19 @@
           <a:p xmlns:a="http://schemas.openxmlformats.org/drawingml/2006/main">
             <a:r>
               <a:rPr sz="1400"/>
-              <a:t>Bron: Boek 4, editie books34-v3, gedrukte complete-boekpagina 7, 11–14. https://github.com/meijer1973/4veco-lessen/blob/e734532a42b27732ac25ce990fc9448b12309d28/edities/books34-v3/books/book-4/output/Boek_4_Compleet_v3.pdf</a:t>
+              <a:t>Bron: Boek 4, editie books34-v3, gedrukte complete-boekpagina 7, 11–14. https://github.com/meijer1973/4veco-lessen/blob/0356afb6cac2dd43adbe9f63b872aaf423efc914/edities/books34-v3/books/book-4/output/Boek_4_Compleet_v3.pdf</a:t>
             </a:r>
           </a:p>
           <a:p xmlns:a="http://schemas.openxmlformats.org/drawingml/2006/main">
             <a:r>
               <a:rPr sz="1400"/>
-              <a:t>Manuscript en antwoordmodel: https://github.com/meijer1973/4veco-lessen/blob/e734532a42b27732ac25ce990fc9448b12309d28/edities/books34-v3/books/book-4/chapters/4.1/4.1.1%20manuscript.md en https://github.com/meijer1973/4veco-lessen/blob/e734532a42b27732ac25ce990fc9448b12309d28/edities/books34-v3/books/book-4/chapters/4.1/Antwoorden.md</a:t>
+              <a:t>Manuscript en antwoordmodel: https://github.com/meijer1973/4veco-lessen/blob/0356afb6cac2dd43adbe9f63b872aaf423efc914/edities/books34-v3/books/book-4/chapters/4.1/4.1.1%20manuscript.md en https://github.com/meijer1973/4veco-lessen/blob/0356afb6cac2dd43adbe9f63b872aaf423efc914/edities/books34-v3/books/book-4/chapters/4.1/Antwoorden.md</a:t>
             </a:r>
           </a:p>
           <a:p xmlns:a="http://schemas.openxmlformats.org/drawingml/2006/main">
             <a:r>
               <a:rPr sz="1400"/>
-              <a:t>Voorkennis: https://github.com/meijer1973/4veco-lessen/blob/e734532a42b27732ac25ce990fc9448b12309d28/edities/books34-v3/books/book-3/output/Boek_3_Compleet_v3.pdf, gedrukte p. 63, 70–72. Startantwoorden alleen voor feedback na eigen poging: 1a MK=0,20q+2; q=30. 1b TO=240, TK=190, winst=50 euro/week, GTK=6,333… euro/kg. 2a economische winst=0; 2b normale vergoeding=180 euro/week.</a:t>
+              <a:t>Voorkennis: https://github.com/meijer1973/4veco-lessen/blob/0356afb6cac2dd43adbe9f63b872aaf423efc914/edities/books34-v3/books/book-3/output/Boek_3_Compleet_v3.pdf, gedrukte p. 63, 70–72. Startantwoorden alleen voor feedback na eigen poging: 1a MK=0,20q+2; q=30. 1b TO=240, TK=190, winst=50 euro/week, GTK=6,333… euro/kg. 2a economische winst=0; 2b normale vergoeding=180 euro/week.</a:t>
             </a:r>
           </a:p>
         </p:txBody>
@@ -661,13 +661,13 @@
           <a:p xmlns:a="http://schemas.openxmlformats.org/drawingml/2006/main">
             <a:r>
               <a:rPr sz="1400"/>
-              <a:t>Bron: Boek 4, editie books34-v3, gedrukte complete-boekpagina 7–10. https://github.com/meijer1973/4veco-lessen/blob/e734532a42b27732ac25ce990fc9448b12309d28/edities/books34-v3/books/book-4/output/Boek_4_Compleet_v3.pdf</a:t>
+              <a:t>Bron: Boek 4, editie books34-v3, gedrukte complete-boekpagina 7–10. https://github.com/meijer1973/4veco-lessen/blob/0356afb6cac2dd43adbe9f63b872aaf423efc914/edities/books34-v3/books/book-4/output/Boek_4_Compleet_v3.pdf</a:t>
             </a:r>
           </a:p>
           <a:p xmlns:a="http://schemas.openxmlformats.org/drawingml/2006/main">
             <a:r>
               <a:rPr sz="1400"/>
-              <a:t>Manuscript en antwoordmodel: https://github.com/meijer1973/4veco-lessen/blob/e734532a42b27732ac25ce990fc9448b12309d28/edities/books34-v3/books/book-4/chapters/4.1/4.1.1%20manuscript.md en https://github.com/meijer1973/4veco-lessen/blob/e734532a42b27732ac25ce990fc9448b12309d28/edities/books34-v3/books/book-4/chapters/4.1/Antwoorden.md</a:t>
+              <a:t>Manuscript en antwoordmodel: https://github.com/meijer1973/4veco-lessen/blob/0356afb6cac2dd43adbe9f63b872aaf423efc914/edities/books34-v3/books/book-4/chapters/4.1/4.1.1%20manuscript.md en https://github.com/meijer1973/4veco-lessen/blob/0356afb6cac2dd43adbe9f63b872aaf423efc914/edities/books34-v3/books/book-4/chapters/4.1/Antwoorden.md</a:t>
             </a:r>
           </a:p>
           <a:p xmlns:a="http://schemas.openxmlformats.org/drawingml/2006/main">
@@ -792,13 +792,13 @@
           <a:p xmlns:a="http://schemas.openxmlformats.org/drawingml/2006/main">
             <a:r>
               <a:rPr sz="1400"/>
-              <a:t>Bron: Boek 4, editie books34-v3, gedrukte complete-boekpagina 9. https://github.com/meijer1973/4veco-lessen/blob/e734532a42b27732ac25ce990fc9448b12309d28/edities/books34-v3/books/book-4/output/Boek_4_Compleet_v3.pdf</a:t>
+              <a:t>Bron: Boek 4, editie books34-v3, gedrukte complete-boekpagina 9. https://github.com/meijer1973/4veco-lessen/blob/0356afb6cac2dd43adbe9f63b872aaf423efc914/edities/books34-v3/books/book-4/output/Boek_4_Compleet_v3.pdf</a:t>
             </a:r>
           </a:p>
           <a:p xmlns:a="http://schemas.openxmlformats.org/drawingml/2006/main">
             <a:r>
               <a:rPr sz="1400"/>
-              <a:t>Manuscript en antwoordmodel: https://github.com/meijer1973/4veco-lessen/blob/e734532a42b27732ac25ce990fc9448b12309d28/edities/books34-v3/books/book-4/chapters/4.1/4.1.1%20manuscript.md en https://github.com/meijer1973/4veco-lessen/blob/e734532a42b27732ac25ce990fc9448b12309d28/edities/books34-v3/books/book-4/chapters/4.1/Antwoorden.md</a:t>
+              <a:t>Manuscript en antwoordmodel: https://github.com/meijer1973/4veco-lessen/blob/0356afb6cac2dd43adbe9f63b872aaf423efc914/edities/books34-v3/books/book-4/chapters/4.1/4.1.1%20manuscript.md en https://github.com/meijer1973/4veco-lessen/blob/0356afb6cac2dd43adbe9f63b872aaf423efc914/edities/books34-v3/books/book-4/chapters/4.1/Antwoorden.md</a:t>
             </a:r>
           </a:p>
           <a:p xmlns:a="http://schemas.openxmlformats.org/drawingml/2006/main">
@@ -923,13 +923,13 @@
           <a:p xmlns:a="http://schemas.openxmlformats.org/drawingml/2006/main">
             <a:r>
               <a:rPr sz="1400"/>
-              <a:t>Bron: Boek 4, editie books34-v3, gedrukte complete-boekpagina 9. https://github.com/meijer1973/4veco-lessen/blob/e734532a42b27732ac25ce990fc9448b12309d28/edities/books34-v3/books/book-4/output/Boek_4_Compleet_v3.pdf</a:t>
+              <a:t>Bron: Boek 4, editie books34-v3, gedrukte complete-boekpagina 9. https://github.com/meijer1973/4veco-lessen/blob/0356afb6cac2dd43adbe9f63b872aaf423efc914/edities/books34-v3/books/book-4/output/Boek_4_Compleet_v3.pdf</a:t>
             </a:r>
           </a:p>
           <a:p xmlns:a="http://schemas.openxmlformats.org/drawingml/2006/main">
             <a:r>
               <a:rPr sz="1400"/>
-              <a:t>Manuscript en antwoordmodel: https://github.com/meijer1973/4veco-lessen/blob/e734532a42b27732ac25ce990fc9448b12309d28/edities/books34-v3/books/book-4/chapters/4.1/4.1.1%20manuscript.md en https://github.com/meijer1973/4veco-lessen/blob/e734532a42b27732ac25ce990fc9448b12309d28/edities/books34-v3/books/book-4/chapters/4.1/Antwoorden.md</a:t>
+              <a:t>Manuscript en antwoordmodel: https://github.com/meijer1973/4veco-lessen/blob/0356afb6cac2dd43adbe9f63b872aaf423efc914/edities/books34-v3/books/book-4/chapters/4.1/4.1.1%20manuscript.md en https://github.com/meijer1973/4veco-lessen/blob/0356afb6cac2dd43adbe9f63b872aaf423efc914/edities/books34-v3/books/book-4/chapters/4.1/Antwoorden.md</a:t>
             </a:r>
           </a:p>
           <a:p xmlns:a="http://schemas.openxmlformats.org/drawingml/2006/main">
@@ -1054,13 +1054,13 @@
           <a:p xmlns:a="http://schemas.openxmlformats.org/drawingml/2006/main">
             <a:r>
               <a:rPr sz="1400"/>
-              <a:t>Bron: Boek 4, editie books34-v3, gedrukte complete-boekpagina 9–10. https://github.com/meijer1973/4veco-lessen/blob/e734532a42b27732ac25ce990fc9448b12309d28/edities/books34-v3/books/book-4/output/Boek_4_Compleet_v3.pdf</a:t>
+              <a:t>Bron: Boek 4, editie books34-v3, gedrukte complete-boekpagina 9–10. https://github.com/meijer1973/4veco-lessen/blob/0356afb6cac2dd43adbe9f63b872aaf423efc914/edities/books34-v3/books/book-4/output/Boek_4_Compleet_v3.pdf</a:t>
             </a:r>
           </a:p>
           <a:p xmlns:a="http://schemas.openxmlformats.org/drawingml/2006/main">
             <a:r>
               <a:rPr sz="1400"/>
-              <a:t>Manuscript en antwoordmodel: https://github.com/meijer1973/4veco-lessen/blob/e734532a42b27732ac25ce990fc9448b12309d28/edities/books34-v3/books/book-4/chapters/4.1/4.1.1%20manuscript.md en https://github.com/meijer1973/4veco-lessen/blob/e734532a42b27732ac25ce990fc9448b12309d28/edities/books34-v3/books/book-4/chapters/4.1/Antwoorden.md</a:t>
+              <a:t>Manuscript en antwoordmodel: https://github.com/meijer1973/4veco-lessen/blob/0356afb6cac2dd43adbe9f63b872aaf423efc914/edities/books34-v3/books/book-4/chapters/4.1/4.1.1%20manuscript.md en https://github.com/meijer1973/4veco-lessen/blob/0356afb6cac2dd43adbe9f63b872aaf423efc914/edities/books34-v3/books/book-4/chapters/4.1/Antwoorden.md</a:t>
             </a:r>
           </a:p>
           <a:p xmlns:a="http://schemas.openxmlformats.org/drawingml/2006/main">
@@ -1185,13 +1185,13 @@
           <a:p xmlns:a="http://schemas.openxmlformats.org/drawingml/2006/main">
             <a:r>
               <a:rPr sz="1400"/>
-              <a:t>Bron: Boek 4, editie books34-v3, gedrukte complete-boekpagina 7–10. https://github.com/meijer1973/4veco-lessen/blob/e734532a42b27732ac25ce990fc9448b12309d28/edities/books34-v3/books/book-4/output/Boek_4_Compleet_v3.pdf</a:t>
+              <a:t>Bron: Boek 4, editie books34-v3, gedrukte complete-boekpagina 7–10. https://github.com/meijer1973/4veco-lessen/blob/0356afb6cac2dd43adbe9f63b872aaf423efc914/edities/books34-v3/books/book-4/output/Boek_4_Compleet_v3.pdf</a:t>
             </a:r>
           </a:p>
           <a:p xmlns:a="http://schemas.openxmlformats.org/drawingml/2006/main">
             <a:r>
               <a:rPr sz="1400"/>
-              <a:t>Manuscript en antwoordmodel: https://github.com/meijer1973/4veco-lessen/blob/e734532a42b27732ac25ce990fc9448b12309d28/edities/books34-v3/books/book-4/chapters/4.1/4.1.1%20manuscript.md en https://github.com/meijer1973/4veco-lessen/blob/e734532a42b27732ac25ce990fc9448b12309d28/edities/books34-v3/books/book-4/chapters/4.1/Antwoorden.md</a:t>
+              <a:t>Manuscript en antwoordmodel: https://github.com/meijer1973/4veco-lessen/blob/0356afb6cac2dd43adbe9f63b872aaf423efc914/edities/books34-v3/books/book-4/chapters/4.1/4.1.1%20manuscript.md en https://github.com/meijer1973/4veco-lessen/blob/0356afb6cac2dd43adbe9f63b872aaf423efc914/edities/books34-v3/books/book-4/chapters/4.1/Antwoorden.md</a:t>
             </a:r>
           </a:p>
           <a:p xmlns:a="http://schemas.openxmlformats.org/drawingml/2006/main">
@@ -1316,13 +1316,13 @@
           <a:p xmlns:a="http://schemas.openxmlformats.org/drawingml/2006/main">
             <a:r>
               <a:rPr sz="1400"/>
-              <a:t>Bron: Boek 4, editie books34-v3, gedrukte complete-boekpagina 7–10. https://github.com/meijer1973/4veco-lessen/blob/e734532a42b27732ac25ce990fc9448b12309d28/edities/books34-v3/books/book-4/output/Boek_4_Compleet_v3.pdf</a:t>
+              <a:t>Bron: Boek 4, editie books34-v3, gedrukte complete-boekpagina 7–10. https://github.com/meijer1973/4veco-lessen/blob/0356afb6cac2dd43adbe9f63b872aaf423efc914/edities/books34-v3/books/book-4/output/Boek_4_Compleet_v3.pdf</a:t>
             </a:r>
           </a:p>
           <a:p xmlns:a="http://schemas.openxmlformats.org/drawingml/2006/main">
             <a:r>
               <a:rPr sz="1400"/>
-              <a:t>Manuscript en antwoordmodel: https://github.com/meijer1973/4veco-lessen/blob/e734532a42b27732ac25ce990fc9448b12309d28/edities/books34-v3/books/book-4/chapters/4.1/4.1.1%20manuscript.md en https://github.com/meijer1973/4veco-lessen/blob/e734532a42b27732ac25ce990fc9448b12309d28/edities/books34-v3/books/book-4/chapters/4.1/Antwoorden.md</a:t>
+              <a:t>Manuscript en antwoordmodel: https://github.com/meijer1973/4veco-lessen/blob/0356afb6cac2dd43adbe9f63b872aaf423efc914/edities/books34-v3/books/book-4/chapters/4.1/4.1.1%20manuscript.md en https://github.com/meijer1973/4veco-lessen/blob/0356afb6cac2dd43adbe9f63b872aaf423efc914/edities/books34-v3/books/book-4/chapters/4.1/Antwoorden.md</a:t>
             </a:r>
           </a:p>
           <a:p xmlns:a="http://schemas.openxmlformats.org/drawingml/2006/main">
@@ -1459,19 +1459,19 @@
           <a:p xmlns:a="http://schemas.openxmlformats.org/drawingml/2006/main">
             <a:r>
               <a:rPr sz="1400"/>
-              <a:t>Bron: Boek 4, editie books34-v3, gedrukte complete-boekpagina 7, 11–14. https://github.com/meijer1973/4veco-lessen/blob/e734532a42b27732ac25ce990fc9448b12309d28/edities/books34-v3/books/book-4/output/Boek_4_Compleet_v3.pdf</a:t>
+              <a:t>Bron: Boek 4, editie books34-v3, gedrukte complete-boekpagina 7, 11–14. https://github.com/meijer1973/4veco-lessen/blob/0356afb6cac2dd43adbe9f63b872aaf423efc914/edities/books34-v3/books/book-4/output/Boek_4_Compleet_v3.pdf</a:t>
             </a:r>
           </a:p>
           <a:p xmlns:a="http://schemas.openxmlformats.org/drawingml/2006/main">
             <a:r>
               <a:rPr sz="1400"/>
-              <a:t>Manuscript en antwoordmodel: https://github.com/meijer1973/4veco-lessen/blob/e734532a42b27732ac25ce990fc9448b12309d28/edities/books34-v3/books/book-4/chapters/4.1/4.1.1%20manuscript.md en https://github.com/meijer1973/4veco-lessen/blob/e734532a42b27732ac25ce990fc9448b12309d28/edities/books34-v3/books/book-4/chapters/4.1/Antwoorden.md</a:t>
+              <a:t>Manuscript en antwoordmodel: https://github.com/meijer1973/4veco-lessen/blob/0356afb6cac2dd43adbe9f63b872aaf423efc914/edities/books34-v3/books/book-4/chapters/4.1/4.1.1%20manuscript.md en https://github.com/meijer1973/4veco-lessen/blob/0356afb6cac2dd43adbe9f63b872aaf423efc914/edities/books34-v3/books/book-4/chapters/4.1/Antwoorden.md</a:t>
             </a:r>
           </a:p>
           <a:p xmlns:a="http://schemas.openxmlformats.org/drawingml/2006/main">
             <a:r>
               <a:rPr sz="1400"/>
-              <a:t>Voorkennis: https://github.com/meijer1973/4veco-lessen/blob/e734532a42b27732ac25ce990fc9448b12309d28/edities/books34-v3/books/book-3/output/Boek_3_Compleet_v3.pdf, gedrukte p. 63, 70–72. Startantwoorden alleen voor feedback na eigen poging: 1a MK=0,20q+2; q=30. 1b TO=240, TK=190, winst=50 euro/week, GTK=6,333… euro/kg. 2a economische winst=0; 2b normale vergoeding=180 euro/week.</a:t>
+              <a:t>Voorkennis: https://github.com/meijer1973/4veco-lessen/blob/0356afb6cac2dd43adbe9f63b872aaf423efc914/edities/books34-v3/books/book-3/output/Boek_3_Compleet_v3.pdf, gedrukte p. 63, 70–72. Startantwoorden alleen voor feedback na eigen poging: 1a MK=0,20q+2; q=30. 1b TO=240, TK=190, winst=50 euro/week, GTK=6,333… euro/kg. 2a economische winst=0; 2b normale vergoeding=180 euro/week.</a:t>
             </a:r>
           </a:p>
         </p:txBody>
@@ -1590,13 +1590,13 @@
           <a:p xmlns:a="http://schemas.openxmlformats.org/drawingml/2006/main">
             <a:r>
               <a:rPr sz="1400"/>
-              <a:t>Bron: Boek 4, editie books34-v3, gedrukte complete-boekpagina 14. https://github.com/meijer1973/4veco-lessen/blob/e734532a42b27732ac25ce990fc9448b12309d28/edities/books34-v3/books/book-4/output/Boek_4_Compleet_v3.pdf</a:t>
+              <a:t>Bron: Boek 4, editie books34-v3, gedrukte complete-boekpagina 14. https://github.com/meijer1973/4veco-lessen/blob/0356afb6cac2dd43adbe9f63b872aaf423efc914/edities/books34-v3/books/book-4/output/Boek_4_Compleet_v3.pdf</a:t>
             </a:r>
           </a:p>
           <a:p xmlns:a="http://schemas.openxmlformats.org/drawingml/2006/main">
             <a:r>
               <a:rPr sz="1400"/>
-              <a:t>Manuscript en antwoordmodel: https://github.com/meijer1973/4veco-lessen/blob/e734532a42b27732ac25ce990fc9448b12309d28/edities/books34-v3/books/book-4/chapters/4.1/4.1.1%20manuscript.md en https://github.com/meijer1973/4veco-lessen/blob/e734532a42b27732ac25ce990fc9448b12309d28/edities/books34-v3/books/book-4/chapters/4.1/Antwoorden.md</a:t>
+              <a:t>Manuscript en antwoordmodel: https://github.com/meijer1973/4veco-lessen/blob/0356afb6cac2dd43adbe9f63b872aaf423efc914/edities/books34-v3/books/book-4/chapters/4.1/4.1.1%20manuscript.md en https://github.com/meijer1973/4veco-lessen/blob/0356afb6cac2dd43adbe9f63b872aaf423efc914/edities/books34-v3/books/book-4/chapters/4.1/Antwoorden.md</a:t>
             </a:r>
           </a:p>
           <a:p xmlns:a="http://schemas.openxmlformats.org/drawingml/2006/main">
@@ -1685,7 +1685,7 @@
           <a:p xmlns:a="http://schemas.openxmlformats.org/drawingml/2006/main">
             <a:r>
               <a:rPr sz="1400"/>
-              <a:t>Uitleg: Ongewijzigde oorspronkelijke bronfiguur uit het boek, met historische assetnaam 3.2.3_target.svg. Alle labels, schalen en gegevens blijven zichtbaar. Links staat Q in duizend kg per week; rechts q in kg per week. Geef hier nog geen oplossingen.</a:t>
+              <a:t>Uitleg: Actuele bronfiguur uit het boek, begrensd op de capaciteit van de oorspronkelijke groep bedrijven, met historische assetnaam 3.2.3_target.svg. Alle labels, schalen en gegevens blijven zichtbaar. Links staat Q in duizend kg per week; rechts q in kg per week. Geef hier nog geen oplossingen.</a:t>
             </a:r>
           </a:p>
           <a:p xmlns:a="http://schemas.openxmlformats.org/drawingml/2006/main">
@@ -1721,13 +1721,13 @@
           <a:p xmlns:a="http://schemas.openxmlformats.org/drawingml/2006/main">
             <a:r>
               <a:rPr sz="1400"/>
-              <a:t>Bron: Boek 4, editie books34-v3, gedrukte complete-boekpagina 14. https://github.com/meijer1973/4veco-lessen/blob/e734532a42b27732ac25ce990fc9448b12309d28/edities/books34-v3/books/book-4/output/Boek_4_Compleet_v3.pdf</a:t>
+              <a:t>Bron: Boek 4, editie books34-v3, gedrukte complete-boekpagina 14. https://github.com/meijer1973/4veco-lessen/blob/0356afb6cac2dd43adbe9f63b872aaf423efc914/edities/books34-v3/books/book-4/output/Boek_4_Compleet_v3.pdf</a:t>
             </a:r>
           </a:p>
           <a:p xmlns:a="http://schemas.openxmlformats.org/drawingml/2006/main">
             <a:r>
               <a:rPr sz="1400"/>
-              <a:t>Manuscript en antwoordmodel: https://github.com/meijer1973/4veco-lessen/blob/e734532a42b27732ac25ce990fc9448b12309d28/edities/books34-v3/books/book-4/chapters/4.1/4.1.1%20manuscript.md en https://github.com/meijer1973/4veco-lessen/blob/e734532a42b27732ac25ce990fc9448b12309d28/edities/books34-v3/books/book-4/chapters/4.1/Antwoorden.md</a:t>
+              <a:t>Manuscript en antwoordmodel: https://github.com/meijer1973/4veco-lessen/blob/0356afb6cac2dd43adbe9f63b872aaf423efc914/edities/books34-v3/books/book-4/chapters/4.1/4.1.1%20manuscript.md en https://github.com/meijer1973/4veco-lessen/blob/0356afb6cac2dd43adbe9f63b872aaf423efc914/edities/books34-v3/books/book-4/chapters/4.1/Antwoorden.md</a:t>
             </a:r>
           </a:p>
           <a:p xmlns:a="http://schemas.openxmlformats.org/drawingml/2006/main">
@@ -1852,13 +1852,13 @@
           <a:p xmlns:a="http://schemas.openxmlformats.org/drawingml/2006/main">
             <a:r>
               <a:rPr sz="1400"/>
-              <a:t>Bron: Boek 4, editie books34-v3, gedrukte complete-boekpagina 14. https://github.com/meijer1973/4veco-lessen/blob/e734532a42b27732ac25ce990fc9448b12309d28/edities/books34-v3/books/book-4/output/Boek_4_Compleet_v3.pdf</a:t>
+              <a:t>Bron: Boek 4, editie books34-v3, gedrukte complete-boekpagina 14. https://github.com/meijer1973/4veco-lessen/blob/0356afb6cac2dd43adbe9f63b872aaf423efc914/edities/books34-v3/books/book-4/output/Boek_4_Compleet_v3.pdf</a:t>
             </a:r>
           </a:p>
           <a:p xmlns:a="http://schemas.openxmlformats.org/drawingml/2006/main">
             <a:r>
               <a:rPr sz="1400"/>
-              <a:t>Manuscript en antwoordmodel: https://github.com/meijer1973/4veco-lessen/blob/e734532a42b27732ac25ce990fc9448b12309d28/edities/books34-v3/books/book-4/chapters/4.1/4.1.1%20manuscript.md en https://github.com/meijer1973/4veco-lessen/blob/e734532a42b27732ac25ce990fc9448b12309d28/edities/books34-v3/books/book-4/chapters/4.1/Antwoorden.md</a:t>
+              <a:t>Manuscript en antwoordmodel: https://github.com/meijer1973/4veco-lessen/blob/0356afb6cac2dd43adbe9f63b872aaf423efc914/edities/books34-v3/books/book-4/chapters/4.1/4.1.1%20manuscript.md en https://github.com/meijer1973/4veco-lessen/blob/0356afb6cac2dd43adbe9f63b872aaf423efc914/edities/books34-v3/books/book-4/chapters/4.1/Antwoorden.md</a:t>
             </a:r>
           </a:p>
           <a:p xmlns:a="http://schemas.openxmlformats.org/drawingml/2006/main">
@@ -1983,13 +1983,13 @@
           <a:p xmlns:a="http://schemas.openxmlformats.org/drawingml/2006/main">
             <a:r>
               <a:rPr sz="1400"/>
-              <a:t>Bron: Boek 4, editie books34-v3, gedrukte complete-boekpagina 7. https://github.com/meijer1973/4veco-lessen/blob/e734532a42b27732ac25ce990fc9448b12309d28/edities/books34-v3/books/book-4/output/Boek_4_Compleet_v3.pdf</a:t>
+              <a:t>Bron: Boek 4, editie books34-v3, gedrukte complete-boekpagina 7. https://github.com/meijer1973/4veco-lessen/blob/0356afb6cac2dd43adbe9f63b872aaf423efc914/edities/books34-v3/books/book-4/output/Boek_4_Compleet_v3.pdf</a:t>
             </a:r>
           </a:p>
           <a:p xmlns:a="http://schemas.openxmlformats.org/drawingml/2006/main">
             <a:r>
               <a:rPr sz="1400"/>
-              <a:t>Manuscript en antwoordmodel: https://github.com/meijer1973/4veco-lessen/blob/e734532a42b27732ac25ce990fc9448b12309d28/edities/books34-v3/books/book-4/chapters/4.1/4.1.1%20manuscript.md en https://github.com/meijer1973/4veco-lessen/blob/e734532a42b27732ac25ce990fc9448b12309d28/edities/books34-v3/books/book-4/chapters/4.1/Antwoorden.md</a:t>
+              <a:t>Manuscript en antwoordmodel: https://github.com/meijer1973/4veco-lessen/blob/0356afb6cac2dd43adbe9f63b872aaf423efc914/edities/books34-v3/books/book-4/chapters/4.1/4.1.1%20manuscript.md en https://github.com/meijer1973/4veco-lessen/blob/0356afb6cac2dd43adbe9f63b872aaf423efc914/edities/books34-v3/books/book-4/chapters/4.1/Antwoorden.md</a:t>
             </a:r>
           </a:p>
           <a:p xmlns:a="http://schemas.openxmlformats.org/drawingml/2006/main">
@@ -2114,13 +2114,13 @@
           <a:p xmlns:a="http://schemas.openxmlformats.org/drawingml/2006/main">
             <a:r>
               <a:rPr sz="1400"/>
-              <a:t>Bron: Boek 4, editie books34-v3, gedrukte complete-boekpagina 14. https://github.com/meijer1973/4veco-lessen/blob/e734532a42b27732ac25ce990fc9448b12309d28/edities/books34-v3/books/book-4/output/Boek_4_Compleet_v3.pdf</a:t>
+              <a:t>Bron: Boek 4, editie books34-v3, gedrukte complete-boekpagina 14. https://github.com/meijer1973/4veco-lessen/blob/0356afb6cac2dd43adbe9f63b872aaf423efc914/edities/books34-v3/books/book-4/output/Boek_4_Compleet_v3.pdf</a:t>
             </a:r>
           </a:p>
           <a:p xmlns:a="http://schemas.openxmlformats.org/drawingml/2006/main">
             <a:r>
               <a:rPr sz="1400"/>
-              <a:t>Manuscript en antwoordmodel: https://github.com/meijer1973/4veco-lessen/blob/e734532a42b27732ac25ce990fc9448b12309d28/edities/books34-v3/books/book-4/chapters/4.1/4.1.1%20manuscript.md en https://github.com/meijer1973/4veco-lessen/blob/e734532a42b27732ac25ce990fc9448b12309d28/edities/books34-v3/books/book-4/chapters/4.1/Antwoorden.md</a:t>
+              <a:t>Manuscript en antwoordmodel: https://github.com/meijer1973/4veco-lessen/blob/0356afb6cac2dd43adbe9f63b872aaf423efc914/edities/books34-v3/books/book-4/chapters/4.1/4.1.1%20manuscript.md en https://github.com/meijer1973/4veco-lessen/blob/0356afb6cac2dd43adbe9f63b872aaf423efc914/edities/books34-v3/books/book-4/chapters/4.1/Antwoorden.md</a:t>
             </a:r>
           </a:p>
           <a:p xmlns:a="http://schemas.openxmlformats.org/drawingml/2006/main">
@@ -2245,13 +2245,13 @@
           <a:p xmlns:a="http://schemas.openxmlformats.org/drawingml/2006/main">
             <a:r>
               <a:rPr sz="1400"/>
-              <a:t>Bron: Boek 4, editie books34-v3, gedrukte complete-boekpagina 14. https://github.com/meijer1973/4veco-lessen/blob/e734532a42b27732ac25ce990fc9448b12309d28/edities/books34-v3/books/book-4/output/Boek_4_Compleet_v3.pdf</a:t>
+              <a:t>Bron: Boek 4, editie books34-v3, gedrukte complete-boekpagina 14. https://github.com/meijer1973/4veco-lessen/blob/0356afb6cac2dd43adbe9f63b872aaf423efc914/edities/books34-v3/books/book-4/output/Boek_4_Compleet_v3.pdf</a:t>
             </a:r>
           </a:p>
           <a:p xmlns:a="http://schemas.openxmlformats.org/drawingml/2006/main">
             <a:r>
               <a:rPr sz="1400"/>
-              <a:t>Manuscript en antwoordmodel: https://github.com/meijer1973/4veco-lessen/blob/e734532a42b27732ac25ce990fc9448b12309d28/edities/books34-v3/books/book-4/chapters/4.1/4.1.1%20manuscript.md en https://github.com/meijer1973/4veco-lessen/blob/e734532a42b27732ac25ce990fc9448b12309d28/edities/books34-v3/books/book-4/chapters/4.1/Antwoorden.md</a:t>
+              <a:t>Manuscript en antwoordmodel: https://github.com/meijer1973/4veco-lessen/blob/0356afb6cac2dd43adbe9f63b872aaf423efc914/edities/books34-v3/books/book-4/chapters/4.1/4.1.1%20manuscript.md en https://github.com/meijer1973/4veco-lessen/blob/0356afb6cac2dd43adbe9f63b872aaf423efc914/edities/books34-v3/books/book-4/chapters/4.1/Antwoorden.md</a:t>
             </a:r>
           </a:p>
           <a:p xmlns:a="http://schemas.openxmlformats.org/drawingml/2006/main">
@@ -2376,13 +2376,13 @@
           <a:p xmlns:a="http://schemas.openxmlformats.org/drawingml/2006/main">
             <a:r>
               <a:rPr sz="1400"/>
-              <a:t>Bron: Boek 4, editie books34-v3, gedrukte complete-boekpagina 14. https://github.com/meijer1973/4veco-lessen/blob/e734532a42b27732ac25ce990fc9448b12309d28/edities/books34-v3/books/book-4/output/Boek_4_Compleet_v3.pdf</a:t>
+              <a:t>Bron: Boek 4, editie books34-v3, gedrukte complete-boekpagina 14. https://github.com/meijer1973/4veco-lessen/blob/0356afb6cac2dd43adbe9f63b872aaf423efc914/edities/books34-v3/books/book-4/output/Boek_4_Compleet_v3.pdf</a:t>
             </a:r>
           </a:p>
           <a:p xmlns:a="http://schemas.openxmlformats.org/drawingml/2006/main">
             <a:r>
               <a:rPr sz="1400"/>
-              <a:t>Manuscript en antwoordmodel: https://github.com/meijer1973/4veco-lessen/blob/e734532a42b27732ac25ce990fc9448b12309d28/edities/books34-v3/books/book-4/chapters/4.1/4.1.1%20manuscript.md en https://github.com/meijer1973/4veco-lessen/blob/e734532a42b27732ac25ce990fc9448b12309d28/edities/books34-v3/books/book-4/chapters/4.1/Antwoorden.md</a:t>
+              <a:t>Manuscript en antwoordmodel: https://github.com/meijer1973/4veco-lessen/blob/0356afb6cac2dd43adbe9f63b872aaf423efc914/edities/books34-v3/books/book-4/chapters/4.1/4.1.1%20manuscript.md en https://github.com/meijer1973/4veco-lessen/blob/0356afb6cac2dd43adbe9f63b872aaf423efc914/edities/books34-v3/books/book-4/chapters/4.1/Antwoorden.md</a:t>
             </a:r>
           </a:p>
           <a:p xmlns:a="http://schemas.openxmlformats.org/drawingml/2006/main">
@@ -2507,13 +2507,13 @@
           <a:p xmlns:a="http://schemas.openxmlformats.org/drawingml/2006/main">
             <a:r>
               <a:rPr sz="1400"/>
-              <a:t>Bron: Boek 4, editie books34-v3, gedrukte complete-boekpagina 14. https://github.com/meijer1973/4veco-lessen/blob/e734532a42b27732ac25ce990fc9448b12309d28/edities/books34-v3/books/book-4/output/Boek_4_Compleet_v3.pdf</a:t>
+              <a:t>Bron: Boek 4, editie books34-v3, gedrukte complete-boekpagina 14. https://github.com/meijer1973/4veco-lessen/blob/0356afb6cac2dd43adbe9f63b872aaf423efc914/edities/books34-v3/books/book-4/output/Boek_4_Compleet_v3.pdf</a:t>
             </a:r>
           </a:p>
           <a:p xmlns:a="http://schemas.openxmlformats.org/drawingml/2006/main">
             <a:r>
               <a:rPr sz="1400"/>
-              <a:t>Manuscript en antwoordmodel: https://github.com/meijer1973/4veco-lessen/blob/e734532a42b27732ac25ce990fc9448b12309d28/edities/books34-v3/books/book-4/chapters/4.1/4.1.1%20manuscript.md en https://github.com/meijer1973/4veco-lessen/blob/e734532a42b27732ac25ce990fc9448b12309d28/edities/books34-v3/books/book-4/chapters/4.1/Antwoorden.md</a:t>
+              <a:t>Manuscript en antwoordmodel: https://github.com/meijer1973/4veco-lessen/blob/0356afb6cac2dd43adbe9f63b872aaf423efc914/edities/books34-v3/books/book-4/chapters/4.1/4.1.1%20manuscript.md en https://github.com/meijer1973/4veco-lessen/blob/0356afb6cac2dd43adbe9f63b872aaf423efc914/edities/books34-v3/books/book-4/chapters/4.1/Antwoorden.md</a:t>
             </a:r>
           </a:p>
           <a:p xmlns:a="http://schemas.openxmlformats.org/drawingml/2006/main">
@@ -2602,7 +2602,7 @@
           <a:p xmlns:a="http://schemas.openxmlformats.org/drawingml/2006/main">
             <a:r>
               <a:rPr sz="1400"/>
-              <a:t>Uitleg: Lees de langetermijnprijs 8 uit het gegeven minimum GTK. Teken A₁ door het punt op V met P=8: Q=20 duizend kg/week. De oorspronkelijke grafiek bevat V: P=16−0,4Q en A₀: P=4+0,4Q. Met MK=0,04q+4 geeft dit 100 bedrijven aanvankelijk. In de eindsituatie zijn 200 bedrijven met q=100 nodig. Hun gezamenlijke aanbod is A₁: P=4+0,2Q, op het getoonde domein binnen capaciteit. Deze afleiding controleert de getekende lijn; leerlingen hoeven het aantal bedrijven niet te berekenen. Bij P=8 neemt aanbod toe van 10.000 naar 20.000 kg. De bronfiguur trekt de beginlijn door boven de afgeleide totale capaciteit van 25.000 kg. Dat verlengde deel is geen uitvoerbaar aanbod bij 100 bedrijven met elk maximaal 250 kg. Hier eindigt de beginlijn bij die grens; beide benodigde evenwichten liggen eronder.</a:t>
+              <a:t>Uitleg: Lees de langetermijnprijs 8 uit het gegeven minimum GTK. Teken A₁ door het punt op V met P=8: Q=20 duizend kg/week. De oorspronkelijke grafiek bevat V: P=16−0,4Q en A₀: P=4+0,4Q. Met MK=0,04q+4 geeft dit 100 bedrijven aanvankelijk. In de eindsituatie zijn 200 bedrijven met q=100 nodig. Hun gezamenlijke aanbod is A₁: P=4+0,2Q, op het getoonde domein binnen capaciteit. Deze afleiding controleert de getekende lijn; leerlingen hoeven het aantal bedrijven niet te berekenen. Bij P=8 neemt aanbod toe van 10.000 naar 20.000 kg. De beginlijn in het boek en deze presentatie eindigt bij de totale capaciteit van 25.000 kg voor de oorspronkelijke 100 bedrijven. Beide benodigde evenwichten liggen eronder. Na toetreding geldt de gezamenlijke capaciteit van de nieuwe groep bedrijven.</a:t>
             </a:r>
           </a:p>
           <a:p xmlns:a="http://schemas.openxmlformats.org/drawingml/2006/main">
@@ -2638,13 +2638,13 @@
           <a:p xmlns:a="http://schemas.openxmlformats.org/drawingml/2006/main">
             <a:r>
               <a:rPr sz="1400"/>
-              <a:t>Bron: Boek 4, editie books34-v3, gedrukte complete-boekpagina 14. https://github.com/meijer1973/4veco-lessen/blob/e734532a42b27732ac25ce990fc9448b12309d28/edities/books34-v3/books/book-4/output/Boek_4_Compleet_v3.pdf</a:t>
+              <a:t>Bron: Boek 4, editie books34-v3, gedrukte complete-boekpagina 14. https://github.com/meijer1973/4veco-lessen/blob/0356afb6cac2dd43adbe9f63b872aaf423efc914/edities/books34-v3/books/book-4/output/Boek_4_Compleet_v3.pdf</a:t>
             </a:r>
           </a:p>
           <a:p xmlns:a="http://schemas.openxmlformats.org/drawingml/2006/main">
             <a:r>
               <a:rPr sz="1400"/>
-              <a:t>Manuscript en antwoordmodel: https://github.com/meijer1973/4veco-lessen/blob/e734532a42b27732ac25ce990fc9448b12309d28/edities/books34-v3/books/book-4/chapters/4.1/4.1.1%20manuscript.md en https://github.com/meijer1973/4veco-lessen/blob/e734532a42b27732ac25ce990fc9448b12309d28/edities/books34-v3/books/book-4/chapters/4.1/Antwoorden.md</a:t>
+              <a:t>Manuscript en antwoordmodel: https://github.com/meijer1973/4veco-lessen/blob/0356afb6cac2dd43adbe9f63b872aaf423efc914/edities/books34-v3/books/book-4/chapters/4.1/4.1.1%20manuscript.md en https://github.com/meijer1973/4veco-lessen/blob/0356afb6cac2dd43adbe9f63b872aaf423efc914/edities/books34-v3/books/book-4/chapters/4.1/Antwoorden.md</a:t>
             </a:r>
           </a:p>
           <a:p xmlns:a="http://schemas.openxmlformats.org/drawingml/2006/main">
@@ -2769,13 +2769,13 @@
           <a:p xmlns:a="http://schemas.openxmlformats.org/drawingml/2006/main">
             <a:r>
               <a:rPr sz="1400"/>
-              <a:t>Bron: Boek 4, editie books34-v3, gedrukte complete-boekpagina 14. https://github.com/meijer1973/4veco-lessen/blob/e734532a42b27732ac25ce990fc9448b12309d28/edities/books34-v3/books/book-4/output/Boek_4_Compleet_v3.pdf</a:t>
+              <a:t>Bron: Boek 4, editie books34-v3, gedrukte complete-boekpagina 14. https://github.com/meijer1973/4veco-lessen/blob/0356afb6cac2dd43adbe9f63b872aaf423efc914/edities/books34-v3/books/book-4/output/Boek_4_Compleet_v3.pdf</a:t>
             </a:r>
           </a:p>
           <a:p xmlns:a="http://schemas.openxmlformats.org/drawingml/2006/main">
             <a:r>
               <a:rPr sz="1400"/>
-              <a:t>Manuscript en antwoordmodel: https://github.com/meijer1973/4veco-lessen/blob/e734532a42b27732ac25ce990fc9448b12309d28/edities/books34-v3/books/book-4/chapters/4.1/4.1.1%20manuscript.md en https://github.com/meijer1973/4veco-lessen/blob/e734532a42b27732ac25ce990fc9448b12309d28/edities/books34-v3/books/book-4/chapters/4.1/Antwoorden.md</a:t>
+              <a:t>Manuscript en antwoordmodel: https://github.com/meijer1973/4veco-lessen/blob/0356afb6cac2dd43adbe9f63b872aaf423efc914/edities/books34-v3/books/book-4/chapters/4.1/4.1.1%20manuscript.md en https://github.com/meijer1973/4veco-lessen/blob/0356afb6cac2dd43adbe9f63b872aaf423efc914/edities/books34-v3/books/book-4/chapters/4.1/Antwoorden.md</a:t>
             </a:r>
           </a:p>
           <a:p xmlns:a="http://schemas.openxmlformats.org/drawingml/2006/main">
@@ -2900,13 +2900,13 @@
           <a:p xmlns:a="http://schemas.openxmlformats.org/drawingml/2006/main">
             <a:r>
               <a:rPr sz="1400"/>
-              <a:t>Bron: Boek 4, editie books34-v3, gedrukte complete-boekpagina 14. https://github.com/meijer1973/4veco-lessen/blob/e734532a42b27732ac25ce990fc9448b12309d28/edities/books34-v3/books/book-4/output/Boek_4_Compleet_v3.pdf</a:t>
+              <a:t>Bron: Boek 4, editie books34-v3, gedrukte complete-boekpagina 14. https://github.com/meijer1973/4veco-lessen/blob/0356afb6cac2dd43adbe9f63b872aaf423efc914/edities/books34-v3/books/book-4/output/Boek_4_Compleet_v3.pdf</a:t>
             </a:r>
           </a:p>
           <a:p xmlns:a="http://schemas.openxmlformats.org/drawingml/2006/main">
             <a:r>
               <a:rPr sz="1400"/>
-              <a:t>Manuscript en antwoordmodel: https://github.com/meijer1973/4veco-lessen/blob/e734532a42b27732ac25ce990fc9448b12309d28/edities/books34-v3/books/book-4/chapters/4.1/4.1.1%20manuscript.md en https://github.com/meijer1973/4veco-lessen/blob/e734532a42b27732ac25ce990fc9448b12309d28/edities/books34-v3/books/book-4/chapters/4.1/Antwoorden.md</a:t>
+              <a:t>Manuscript en antwoordmodel: https://github.com/meijer1973/4veco-lessen/blob/0356afb6cac2dd43adbe9f63b872aaf423efc914/edities/books34-v3/books/book-4/chapters/4.1/4.1.1%20manuscript.md en https://github.com/meijer1973/4veco-lessen/blob/0356afb6cac2dd43adbe9f63b872aaf423efc914/edities/books34-v3/books/book-4/chapters/4.1/Antwoorden.md</a:t>
             </a:r>
           </a:p>
           <a:p xmlns:a="http://schemas.openxmlformats.org/drawingml/2006/main">
@@ -3031,13 +3031,13 @@
           <a:p xmlns:a="http://schemas.openxmlformats.org/drawingml/2006/main">
             <a:r>
               <a:rPr sz="1400"/>
-              <a:t>Bron: Boek 4, editie books34-v3, gedrukte complete-boekpagina 14. https://github.com/meijer1973/4veco-lessen/blob/e734532a42b27732ac25ce990fc9448b12309d28/edities/books34-v3/books/book-4/output/Boek_4_Compleet_v3.pdf</a:t>
+              <a:t>Bron: Boek 4, editie books34-v3, gedrukte complete-boekpagina 14. https://github.com/meijer1973/4veco-lessen/blob/0356afb6cac2dd43adbe9f63b872aaf423efc914/edities/books34-v3/books/book-4/output/Boek_4_Compleet_v3.pdf</a:t>
             </a:r>
           </a:p>
           <a:p xmlns:a="http://schemas.openxmlformats.org/drawingml/2006/main">
             <a:r>
               <a:rPr sz="1400"/>
-              <a:t>Manuscript en antwoordmodel: https://github.com/meijer1973/4veco-lessen/blob/e734532a42b27732ac25ce990fc9448b12309d28/edities/books34-v3/books/book-4/chapters/4.1/4.1.1%20manuscript.md en https://github.com/meijer1973/4veco-lessen/blob/e734532a42b27732ac25ce990fc9448b12309d28/edities/books34-v3/books/book-4/chapters/4.1/Antwoorden.md</a:t>
+              <a:t>Manuscript en antwoordmodel: https://github.com/meijer1973/4veco-lessen/blob/0356afb6cac2dd43adbe9f63b872aaf423efc914/edities/books34-v3/books/book-4/chapters/4.1/4.1.1%20manuscript.md en https://github.com/meijer1973/4veco-lessen/blob/0356afb6cac2dd43adbe9f63b872aaf423efc914/edities/books34-v3/books/book-4/chapters/4.1/Antwoorden.md</a:t>
             </a:r>
           </a:p>
           <a:p xmlns:a="http://schemas.openxmlformats.org/drawingml/2006/main">
@@ -3174,19 +3174,19 @@
           <a:p xmlns:a="http://schemas.openxmlformats.org/drawingml/2006/main">
             <a:r>
               <a:rPr sz="1400"/>
-              <a:t>Bron: Boek 4, editie books34-v3, gedrukte complete-boekpagina 7, 11–14. https://github.com/meijer1973/4veco-lessen/blob/e734532a42b27732ac25ce990fc9448b12309d28/edities/books34-v3/books/book-4/output/Boek_4_Compleet_v3.pdf</a:t>
+              <a:t>Bron: Boek 4, editie books34-v3, gedrukte complete-boekpagina 7, 11–14. https://github.com/meijer1973/4veco-lessen/blob/0356afb6cac2dd43adbe9f63b872aaf423efc914/edities/books34-v3/books/book-4/output/Boek_4_Compleet_v3.pdf</a:t>
             </a:r>
           </a:p>
           <a:p xmlns:a="http://schemas.openxmlformats.org/drawingml/2006/main">
             <a:r>
               <a:rPr sz="1400"/>
-              <a:t>Manuscript en antwoordmodel: https://github.com/meijer1973/4veco-lessen/blob/e734532a42b27732ac25ce990fc9448b12309d28/edities/books34-v3/books/book-4/chapters/4.1/4.1.1%20manuscript.md en https://github.com/meijer1973/4veco-lessen/blob/e734532a42b27732ac25ce990fc9448b12309d28/edities/books34-v3/books/book-4/chapters/4.1/Antwoorden.md</a:t>
+              <a:t>Manuscript en antwoordmodel: https://github.com/meijer1973/4veco-lessen/blob/0356afb6cac2dd43adbe9f63b872aaf423efc914/edities/books34-v3/books/book-4/chapters/4.1/4.1.1%20manuscript.md en https://github.com/meijer1973/4veco-lessen/blob/0356afb6cac2dd43adbe9f63b872aaf423efc914/edities/books34-v3/books/book-4/chapters/4.1/Antwoorden.md</a:t>
             </a:r>
           </a:p>
           <a:p xmlns:a="http://schemas.openxmlformats.org/drawingml/2006/main">
             <a:r>
               <a:rPr sz="1400"/>
-              <a:t>Voorkennis: https://github.com/meijer1973/4veco-lessen/blob/e734532a42b27732ac25ce990fc9448b12309d28/edities/books34-v3/books/book-3/output/Boek_3_Compleet_v3.pdf, gedrukte p. 63, 70–72. Startantwoorden alleen voor feedback na eigen poging: 1a MK=0,20q+2; q=30. 1b TO=240, TK=190, winst=50 euro/week, GTK=6,333… euro/kg. 2a economische winst=0; 2b normale vergoeding=180 euro/week.</a:t>
+              <a:t>Voorkennis: https://github.com/meijer1973/4veco-lessen/blob/0356afb6cac2dd43adbe9f63b872aaf423efc914/edities/books34-v3/books/book-3/output/Boek_3_Compleet_v3.pdf, gedrukte p. 63, 70–72. Startantwoorden alleen voor feedback na eigen poging: 1a MK=0,20q+2; q=30. 1b TO=240, TK=190, winst=50 euro/week, GTK=6,333… euro/kg. 2a economische winst=0; 2b normale vergoeding=180 euro/week.</a:t>
             </a:r>
           </a:p>
         </p:txBody>
@@ -3305,13 +3305,13 @@
           <a:p xmlns:a="http://schemas.openxmlformats.org/drawingml/2006/main">
             <a:r>
               <a:rPr sz="1400"/>
-              <a:t>Bron: Boek 4, editie books34-v3, gedrukte complete-boekpagina 7–10. https://github.com/meijer1973/4veco-lessen/blob/e734532a42b27732ac25ce990fc9448b12309d28/edities/books34-v3/books/book-4/output/Boek_4_Compleet_v3.pdf</a:t>
+              <a:t>Bron: Boek 4, editie books34-v3, gedrukte complete-boekpagina 7–10. https://github.com/meijer1973/4veco-lessen/blob/0356afb6cac2dd43adbe9f63b872aaf423efc914/edities/books34-v3/books/book-4/output/Boek_4_Compleet_v3.pdf</a:t>
             </a:r>
           </a:p>
           <a:p xmlns:a="http://schemas.openxmlformats.org/drawingml/2006/main">
             <a:r>
               <a:rPr sz="1400"/>
-              <a:t>Manuscript en antwoordmodel: https://github.com/meijer1973/4veco-lessen/blob/e734532a42b27732ac25ce990fc9448b12309d28/edities/books34-v3/books/book-4/chapters/4.1/4.1.1%20manuscript.md en https://github.com/meijer1973/4veco-lessen/blob/e734532a42b27732ac25ce990fc9448b12309d28/edities/books34-v3/books/book-4/chapters/4.1/Antwoorden.md</a:t>
+              <a:t>Manuscript en antwoordmodel: https://github.com/meijer1973/4veco-lessen/blob/0356afb6cac2dd43adbe9f63b872aaf423efc914/edities/books34-v3/books/book-4/chapters/4.1/4.1.1%20manuscript.md en https://github.com/meijer1973/4veco-lessen/blob/0356afb6cac2dd43adbe9f63b872aaf423efc914/edities/books34-v3/books/book-4/chapters/4.1/Antwoorden.md</a:t>
             </a:r>
           </a:p>
           <a:p xmlns:a="http://schemas.openxmlformats.org/drawingml/2006/main">
@@ -3436,19 +3436,19 @@
           <a:p xmlns:a="http://schemas.openxmlformats.org/drawingml/2006/main">
             <a:r>
               <a:rPr sz="1400"/>
-              <a:t>Bron: Boek 4, editie books34-v3, gedrukte complete-boekpagina 8–10. https://github.com/meijer1973/4veco-lessen/blob/e734532a42b27732ac25ce990fc9448b12309d28/edities/books34-v3/books/book-4/output/Boek_4_Compleet_v3.pdf</a:t>
+              <a:t>Bron: Boek 4, editie books34-v3, gedrukte complete-boekpagina 8–10. https://github.com/meijer1973/4veco-lessen/blob/0356afb6cac2dd43adbe9f63b872aaf423efc914/edities/books34-v3/books/book-4/output/Boek_4_Compleet_v3.pdf</a:t>
             </a:r>
           </a:p>
           <a:p xmlns:a="http://schemas.openxmlformats.org/drawingml/2006/main">
             <a:r>
               <a:rPr sz="1400"/>
-              <a:t>Manuscript en antwoordmodel: https://github.com/meijer1973/4veco-lessen/blob/e734532a42b27732ac25ce990fc9448b12309d28/edities/books34-v3/books/book-4/chapters/4.1/4.1.1%20manuscript.md en https://github.com/meijer1973/4veco-lessen/blob/e734532a42b27732ac25ce990fc9448b12309d28/edities/books34-v3/books/book-4/chapters/4.1/Antwoorden.md</a:t>
+              <a:t>Manuscript en antwoordmodel: https://github.com/meijer1973/4veco-lessen/blob/0356afb6cac2dd43adbe9f63b872aaf423efc914/edities/books34-v3/books/book-4/chapters/4.1/4.1.1%20manuscript.md en https://github.com/meijer1973/4veco-lessen/blob/0356afb6cac2dd43adbe9f63b872aaf423efc914/edities/books34-v3/books/book-4/chapters/4.1/Antwoorden.md</a:t>
             </a:r>
           </a:p>
           <a:p xmlns:a="http://schemas.openxmlformats.org/drawingml/2006/main">
             <a:r>
               <a:rPr sz="1400"/>
-              <a:t>Uitlegvoorbeeld — niet uit het boek. Vezelkorrels: eigen context en gegevens; de boekpagina onderbouwt uitsluitend de methode. Voorkennis met uitleg: Boek 3 p. 63, 70–72. https://github.com/meijer1973/4veco-lessen/blob/e734532a42b27732ac25ce990fc9448b12309d28/edities/books34-v3/books/book-3/output/Boek_3_Compleet_v3.pdf</a:t>
+              <a:t>Uitlegvoorbeeld — niet uit het boek. Vezelkorrels: eigen context en gegevens; de boekpagina onderbouwt uitsluitend de methode. Voorkennis met uitleg: Boek 3 p. 63, 70–72. https://github.com/meijer1973/4veco-lessen/blob/0356afb6cac2dd43adbe9f63b872aaf423efc914/edities/books34-v3/books/book-3/output/Boek_3_Compleet_v3.pdf</a:t>
             </a:r>
           </a:p>
         </p:txBody>
@@ -3567,13 +3567,13 @@
           <a:p xmlns:a="http://schemas.openxmlformats.org/drawingml/2006/main">
             <a:r>
               <a:rPr sz="1400"/>
-              <a:t>Bron: Boek 4, editie books34-v3, gedrukte complete-boekpagina 8–10. https://github.com/meijer1973/4veco-lessen/blob/e734532a42b27732ac25ce990fc9448b12309d28/edities/books34-v3/books/book-4/output/Boek_4_Compleet_v3.pdf</a:t>
+              <a:t>Bron: Boek 4, editie books34-v3, gedrukte complete-boekpagina 8–10. https://github.com/meijer1973/4veco-lessen/blob/0356afb6cac2dd43adbe9f63b872aaf423efc914/edities/books34-v3/books/book-4/output/Boek_4_Compleet_v3.pdf</a:t>
             </a:r>
           </a:p>
           <a:p xmlns:a="http://schemas.openxmlformats.org/drawingml/2006/main">
             <a:r>
               <a:rPr sz="1400"/>
-              <a:t>Manuscript en antwoordmodel: https://github.com/meijer1973/4veco-lessen/blob/e734532a42b27732ac25ce990fc9448b12309d28/edities/books34-v3/books/book-4/chapters/4.1/4.1.1%20manuscript.md en https://github.com/meijer1973/4veco-lessen/blob/e734532a42b27732ac25ce990fc9448b12309d28/edities/books34-v3/books/book-4/chapters/4.1/Antwoorden.md</a:t>
+              <a:t>Manuscript en antwoordmodel: https://github.com/meijer1973/4veco-lessen/blob/0356afb6cac2dd43adbe9f63b872aaf423efc914/edities/books34-v3/books/book-4/chapters/4.1/4.1.1%20manuscript.md en https://github.com/meijer1973/4veco-lessen/blob/0356afb6cac2dd43adbe9f63b872aaf423efc914/edities/books34-v3/books/book-4/chapters/4.1/Antwoorden.md</a:t>
             </a:r>
           </a:p>
           <a:p xmlns:a="http://schemas.openxmlformats.org/drawingml/2006/main">
@@ -3698,13 +3698,13 @@
           <a:p xmlns:a="http://schemas.openxmlformats.org/drawingml/2006/main">
             <a:r>
               <a:rPr sz="1400"/>
-              <a:t>Bron: Boek 4, editie books34-v3, gedrukte complete-boekpagina 8. https://github.com/meijer1973/4veco-lessen/blob/e734532a42b27732ac25ce990fc9448b12309d28/edities/books34-v3/books/book-4/output/Boek_4_Compleet_v3.pdf</a:t>
+              <a:t>Bron: Boek 4, editie books34-v3, gedrukte complete-boekpagina 8. https://github.com/meijer1973/4veco-lessen/blob/0356afb6cac2dd43adbe9f63b872aaf423efc914/edities/books34-v3/books/book-4/output/Boek_4_Compleet_v3.pdf</a:t>
             </a:r>
           </a:p>
           <a:p xmlns:a="http://schemas.openxmlformats.org/drawingml/2006/main">
             <a:r>
               <a:rPr sz="1400"/>
-              <a:t>Manuscript en antwoordmodel: https://github.com/meijer1973/4veco-lessen/blob/e734532a42b27732ac25ce990fc9448b12309d28/edities/books34-v3/books/book-4/chapters/4.1/4.1.1%20manuscript.md en https://github.com/meijer1973/4veco-lessen/blob/e734532a42b27732ac25ce990fc9448b12309d28/edities/books34-v3/books/book-4/chapters/4.1/Antwoorden.md</a:t>
+              <a:t>Manuscript en antwoordmodel: https://github.com/meijer1973/4veco-lessen/blob/0356afb6cac2dd43adbe9f63b872aaf423efc914/edities/books34-v3/books/book-4/chapters/4.1/4.1.1%20manuscript.md en https://github.com/meijer1973/4veco-lessen/blob/0356afb6cac2dd43adbe9f63b872aaf423efc914/edities/books34-v3/books/book-4/chapters/4.1/Antwoorden.md</a:t>
             </a:r>
           </a:p>
           <a:p xmlns:a="http://schemas.openxmlformats.org/drawingml/2006/main">
@@ -3829,13 +3829,13 @@
           <a:p xmlns:a="http://schemas.openxmlformats.org/drawingml/2006/main">
             <a:r>
               <a:rPr sz="1400"/>
-              <a:t>Bron: Boek 4, editie books34-v3, gedrukte complete-boekpagina 8, 10. https://github.com/meijer1973/4veco-lessen/blob/e734532a42b27732ac25ce990fc9448b12309d28/edities/books34-v3/books/book-4/output/Boek_4_Compleet_v3.pdf</a:t>
+              <a:t>Bron: Boek 4, editie books34-v3, gedrukte complete-boekpagina 8, 10. https://github.com/meijer1973/4veco-lessen/blob/0356afb6cac2dd43adbe9f63b872aaf423efc914/edities/books34-v3/books/book-4/output/Boek_4_Compleet_v3.pdf</a:t>
             </a:r>
           </a:p>
           <a:p xmlns:a="http://schemas.openxmlformats.org/drawingml/2006/main">
             <a:r>
               <a:rPr sz="1400"/>
-              <a:t>Manuscript en antwoordmodel: https://github.com/meijer1973/4veco-lessen/blob/e734532a42b27732ac25ce990fc9448b12309d28/edities/books34-v3/books/book-4/chapters/4.1/4.1.1%20manuscript.md en https://github.com/meijer1973/4veco-lessen/blob/e734532a42b27732ac25ce990fc9448b12309d28/edities/books34-v3/books/book-4/chapters/4.1/Antwoorden.md</a:t>
+              <a:t>Manuscript en antwoordmodel: https://github.com/meijer1973/4veco-lessen/blob/0356afb6cac2dd43adbe9f63b872aaf423efc914/edities/books34-v3/books/book-4/chapters/4.1/4.1.1%20manuscript.md en https://github.com/meijer1973/4veco-lessen/blob/0356afb6cac2dd43adbe9f63b872aaf423efc914/edities/books34-v3/books/book-4/chapters/4.1/Antwoorden.md</a:t>
             </a:r>
           </a:p>
           <a:p xmlns:a="http://schemas.openxmlformats.org/drawingml/2006/main">
@@ -3960,13 +3960,13 @@
           <a:p xmlns:a="http://schemas.openxmlformats.org/drawingml/2006/main">
             <a:r>
               <a:rPr sz="1400"/>
-              <a:t>Bron: Boek 4, editie books34-v3, gedrukte complete-boekpagina 8, 10. https://github.com/meijer1973/4veco-lessen/blob/e734532a42b27732ac25ce990fc9448b12309d28/edities/books34-v3/books/book-4/output/Boek_4_Compleet_v3.pdf</a:t>
+              <a:t>Bron: Boek 4, editie books34-v3, gedrukte complete-boekpagina 8, 10. https://github.com/meijer1973/4veco-lessen/blob/0356afb6cac2dd43adbe9f63b872aaf423efc914/edities/books34-v3/books/book-4/output/Boek_4_Compleet_v3.pdf</a:t>
             </a:r>
           </a:p>
           <a:p xmlns:a="http://schemas.openxmlformats.org/drawingml/2006/main">
             <a:r>
               <a:rPr sz="1400"/>
-              <a:t>Manuscript en antwoordmodel: https://github.com/meijer1973/4veco-lessen/blob/e734532a42b27732ac25ce990fc9448b12309d28/edities/books34-v3/books/book-4/chapters/4.1/4.1.1%20manuscript.md en https://github.com/meijer1973/4veco-lessen/blob/e734532a42b27732ac25ce990fc9448b12309d28/edities/books34-v3/books/book-4/chapters/4.1/Antwoorden.md</a:t>
+              <a:t>Manuscript en antwoordmodel: https://github.com/meijer1973/4veco-lessen/blob/0356afb6cac2dd43adbe9f63b872aaf423efc914/edities/books34-v3/books/book-4/chapters/4.1/4.1.1%20manuscript.md en https://github.com/meijer1973/4veco-lessen/blob/0356afb6cac2dd43adbe9f63b872aaf423efc914/edities/books34-v3/books/book-4/chapters/4.1/Antwoorden.md</a:t>
             </a:r>
           </a:p>
           <a:p xmlns:a="http://schemas.openxmlformats.org/drawingml/2006/main">
@@ -4091,13 +4091,13 @@
           <a:p xmlns:a="http://schemas.openxmlformats.org/drawingml/2006/main">
             <a:r>
               <a:rPr sz="1400"/>
-              <a:t>Bron: Boek 4, editie books34-v3, gedrukte complete-boekpagina 10. https://github.com/meijer1973/4veco-lessen/blob/e734532a42b27732ac25ce990fc9448b12309d28/edities/books34-v3/books/book-4/output/Boek_4_Compleet_v3.pdf</a:t>
+              <a:t>Bron: Boek 4, editie books34-v3, gedrukte complete-boekpagina 10. https://github.com/meijer1973/4veco-lessen/blob/0356afb6cac2dd43adbe9f63b872aaf423efc914/edities/books34-v3/books/book-4/output/Boek_4_Compleet_v3.pdf</a:t>
             </a:r>
           </a:p>
           <a:p xmlns:a="http://schemas.openxmlformats.org/drawingml/2006/main">
             <a:r>
               <a:rPr sz="1400"/>
-              <a:t>Manuscript en antwoordmodel: https://github.com/meijer1973/4veco-lessen/blob/e734532a42b27732ac25ce990fc9448b12309d28/edities/books34-v3/books/book-4/chapters/4.1/4.1.1%20manuscript.md en https://github.com/meijer1973/4veco-lessen/blob/e734532a42b27732ac25ce990fc9448b12309d28/edities/books34-v3/books/book-4/chapters/4.1/Antwoorden.md</a:t>
+              <a:t>Manuscript en antwoordmodel: https://github.com/meijer1973/4veco-lessen/blob/0356afb6cac2dd43adbe9f63b872aaf423efc914/edities/books34-v3/books/book-4/chapters/4.1/4.1.1%20manuscript.md en https://github.com/meijer1973/4veco-lessen/blob/0356afb6cac2dd43adbe9f63b872aaf423efc914/edities/books34-v3/books/book-4/chapters/4.1/Antwoorden.md</a:t>
             </a:r>
           </a:p>
           <a:p xmlns:a="http://schemas.openxmlformats.org/drawingml/2006/main">

</xml_diff>